<commit_message>
Update flyers and business card: current prices, Texas-only, new card colors/order (Oct 27)
</commit_message>
<xml_diff>
--- a/assets/Clear-Plan-Webinar-Dec11.pptx
+++ b/assets/Clear-Plan-Webinar-Dec11.pptx
@@ -514,7 +514,7 @@
           <a:lstStyle/>
           <a:p>
             <a:r>
-              <a:t>[Minutes 0–2] Welcome everyone. Say: December is busy, so tonight is short and useful — we get your family's papers and plan ready so January starts calm. No cost, no sales pitch. Questions at the end; registered questions first.</a:t>
+              <a:t>[Minutes 0–2] Welcome everyone. Tonight is for families whose teen turns 18 in 2027 — or soon after. Turning 18 changes the rules in big ways, and starting early makes all of it smoother. No cost, no sales pitch. Questions at the end; registered questions first.</a:t>
             </a:r>
           </a:p>
         </p:txBody>
@@ -584,7 +584,7 @@
           <a:lstStyle/>
           <a:p>
             <a:r>
-              <a:t>[Minutes 30–33] Handle with care — this is education, not a pitch. The point: a child's plan is only as strong as the parents' protection. Invite questions at the free talk.</a:t>
+              <a:t>[Minutes 30–33] End teaching with action. Every family's dates differ — that is what the free talk sorts out.</a:t>
             </a:r>
           </a:p>
         </p:txBody>
@@ -654,7 +654,7 @@
           <a:lstStyle/>
           <a:p>
             <a:r>
-              <a:t>[Minutes 33–35] End teaching with doable steps. Three things, one month. Then questions.</a:t>
+              <a:t>[Minutes 33–35] Small and doable. Then questions.</a:t>
             </a:r>
           </a:p>
         </p:txBody>
@@ -724,7 +724,7 @@
           <a:lstStyle/>
           <a:p>
             <a:r>
-              <a:t>[Minutes 35–45] Registered questions first, as promised. Keep group answers general; private details belong in the free talk.</a:t>
+              <a:t>[Minutes 35–45] Registered questions first. Keep answers general in the group; family dates and details belong in the free talk.</a:t>
             </a:r>
           </a:p>
         </p:txBody>
@@ -794,7 +794,7 @@
           <a:lstStyle/>
           <a:p>
             <a:r>
-              <a:t>[Close] Wish them a Merry Christmas and a calm start to 2027. Remind them: the first talk is free, and we will be here in January.</a:t>
+              <a:t>[Close] Wish them a Merry Christmas and a calm start to 2027. We will be here in January when the steps start.</a:t>
             </a:r>
           </a:p>
         </p:txBody>
@@ -864,7 +864,7 @@
           <a:lstStyle/>
           <a:p>
             <a:r>
-              <a:t>[Minutes 2–3] Read the road map. Tell them the papers list is the part to write down — or take a photo of the slide.</a:t>
+              <a:t>[Minutes 2–3] Read the road map. Tell them the papers slide is the one to photograph.</a:t>
             </a:r>
           </a:p>
         </p:txBody>
@@ -934,7 +934,7 @@
           <a:lstStyle/>
           <a:p>
             <a:r>
-              <a:t>[Minutes 3–7] This is Southern Oak's specialty, in plain words. Families carry all of this in their heads; a plan puts it on paper, in order, so nothing falls through the cracks.</a:t>
+              <a:t>[Minutes 3–6] Set the stage calmly. This is not scary — it is a change to be ready for, and ready is exactly what tonight does.</a:t>
             </a:r>
           </a:p>
         </p:txBody>
@@ -1004,7 +1004,7 @@
           <a:lstStyle/>
           <a:p>
             <a:r>
-              <a:t>[Minutes 7–11] Walk the four steps slowly. No prices tonight — the first talk is free, and every family's plan is different, just like every child.</a:t>
+              <a:t>[Minutes 6–10] This is the fact families miss most: a no at 15 can become a yes at 18. Never promise a result — SSA decides. But every family with a 17-year-old should ask the question fresh at 18.</a:t>
             </a:r>
           </a:p>
         </p:txBody>
@@ -1074,7 +1074,7 @@
           <a:lstStyle/>
           <a:p>
             <a:r>
-              <a:t>[Minutes 11–14] Use the three ages to make it real. This is Jessica's own line: no plan is the same, just like every disability. Ask families to think about which age fits their child.</a:t>
+              <a:t>[Minutes 10–14] The review is normal and expected — not a punishment. Strong records are the best preparation. Tell families: this year, papers are gold.</a:t>
             </a:r>
           </a:p>
         </p:txBody>
@@ -1144,7 +1144,7 @@
           <a:lstStyle/>
           <a:p>
             <a:r>
-              <a:t>[Minutes 14–18] Gentle and practical. Letters from SSA often have deadlines — opening them is step one. If a letter is confusing, that is a free-talk question.</a:t>
+              <a:t>[Minutes 14–19] DAC is the benefit almost nobody is told about. And the warning matters: when a parent is about to file, talk to us first — filing order can protect the young adult's Medicaid. Never promise amounts.</a:t>
             </a:r>
           </a:p>
         </p:txBody>
@@ -1214,7 +1214,7 @@
           <a:lstStyle/>
           <a:p>
             <a:r>
-              <a:t>[Minutes 18–22] Turning 18 is one of the biggest change points. Families with a 17-year-old should start in January, not the birthday month. Offer the free talk for their family's dates.</a:t>
+              <a:t>[Minutes 19–23] Handle with care. Many families have never heard they have choices here. Our role: explain the questions, help gather the picture, and point them to a Texas attorney for the legal step. Never give legal advice.</a:t>
             </a:r>
           </a:p>
         </p:txBody>
@@ -1284,7 +1284,7 @@
           <a:lstStyle/>
           <a:p>
             <a:r>
-              <a:t>[Minutes 22–27] Read the list slowly — this is the photo-the-slide moment. One folder, five things. Having these ready makes every filing and every appointment easier in 2027.</a:t>
+              <a:t>[Minutes 23–26] Short and practical. The school piece surprises families — suddenly letters come addressed to the student. A written request keeps parents in the loop where the school allows.</a:t>
             </a:r>
           </a:p>
         </p:txBody>
@@ -1354,7 +1354,7 @@
           <a:lstStyle/>
           <a:p>
             <a:r>
-              <a:t>[Minutes 27–30] A clean list helps doctors, SSA, and the family. And the check is free for everyone — say it plainly.</a:t>
+              <a:t>[Minutes 26–30] Read the list slowly — photo-the-slide moment. The holidays are the perfect time: one folder, five things, done before January.</a:t>
             </a:r>
           </a:p>
         </p:txBody>
@@ -4458,7 +4458,7 @@
                 </a:solidFill>
                 <a:latin typeface="Georgia"/>
               </a:rPr>
-              <a:t>The Gift of a Clear Plan</a:t>
+              <a:t>Turning 18: What Changes</a:t>
             </a:r>
           </a:p>
         </p:txBody>
@@ -4493,7 +4493,7 @@
                 </a:solidFill>
                 <a:latin typeface="Calibri"/>
               </a:rPr>
-              <a:t>Start the New Year Ready</a:t>
+              <a:t>What to Do First — Start the New Year Ready</a:t>
             </a:r>
           </a:p>
         </p:txBody>
@@ -4704,7 +4704,7 @@
                 </a:solidFill>
                 <a:latin typeface="Georgia"/>
               </a:rPr>
-              <a:t>Protecting the Parents</a:t>
+              <a:t>Start Early: The January Steps</a:t>
             </a:r>
           </a:p>
         </p:txBody>
@@ -4739,7 +4739,7 @@
                 </a:solidFill>
                 <a:latin typeface="Calibri"/>
               </a:rPr>
-              <a:t>•  If something happened to you, who would care for your child?</a:t>
+              <a:t>•  If your teen turns 18 in 2027, your steps start in January</a:t>
             </a:r>
           </a:p>
           <a:p>
@@ -4751,7 +4751,7 @@
                 </a:solidFill>
                 <a:latin typeface="Calibri"/>
               </a:rPr>
-              <a:t>•  Planning for the parents protects the child</a:t>
+              <a:t>•  Book your free first talk — we map YOUR family's dates</a:t>
             </a:r>
           </a:p>
           <a:p>
@@ -4763,7 +4763,7 @@
                 </a:solidFill>
                 <a:latin typeface="Calibri"/>
               </a:rPr>
-              <a:t>•  Life insurance can pay while you are living, with Living Benefits</a:t>
+              <a:t>•  Gather the folder over the holidays</a:t>
             </a:r>
           </a:p>
           <a:p>
@@ -4775,7 +4775,7 @@
                 </a:solidFill>
                 <a:latin typeface="Calibri"/>
               </a:rPr>
-              <a:t>•  A talk about it is always free — information first, no pressure</a:t>
+              <a:t>•  Ask the DAC question before any parent files anything</a:t>
             </a:r>
           </a:p>
         </p:txBody>
@@ -4951,7 +4951,7 @@
                 </a:solidFill>
                 <a:latin typeface="Georgia"/>
               </a:rPr>
-              <a:t>Your January Small Steps</a:t>
+              <a:t>One Small Step This Week</a:t>
             </a:r>
           </a:p>
         </p:txBody>
@@ -4986,7 +4986,7 @@
                 </a:solidFill>
                 <a:latin typeface="Calibri"/>
               </a:rPr>
-              <a:t>•  Pick three small steps for January:</a:t>
+              <a:t>•  Pick ONE:</a:t>
             </a:r>
           </a:p>
           <a:p>
@@ -4998,7 +4998,7 @@
                 </a:solidFill>
                 <a:latin typeface="Calibri"/>
               </a:rPr>
-              <a:t>•  Make the one folder with the five papers</a:t>
+              <a:t>•  Start the folder with one paper</a:t>
             </a:r>
           </a:p>
           <a:p>
@@ -5010,7 +5010,7 @@
                 </a:solidFill>
                 <a:latin typeface="Calibri"/>
               </a:rPr>
-              <a:t>•  Write the clean medication list</a:t>
+              <a:t>•  Write down your teen's 18th birthday and circle it</a:t>
             </a:r>
           </a:p>
           <a:p>
@@ -5023,18 +5023,6 @@
                 <a:latin typeface="Calibri"/>
               </a:rPr>
               <a:t>•  Book your free first talk</a:t>
-            </a:r>
-          </a:p>
-          <a:p>
-            <a:pPr algn="l"/>
-            <a:r>
-              <a:rPr sz="2700" b="0">
-                <a:solidFill>
-                  <a:srgbClr val="222222"/>
-                </a:solidFill>
-                <a:latin typeface="Calibri"/>
-              </a:rPr>
-              <a:t>•  Small steps in January beat big stress in June</a:t>
             </a:r>
           </a:p>
         </p:txBody>
@@ -5683,7 +5671,7 @@
                 </a:solidFill>
                 <a:latin typeface="Calibri"/>
               </a:rPr>
-              <a:t>•  What a personal plan is — and how one is made</a:t>
+              <a:t>•  Why 18 changes everything</a:t>
             </a:r>
           </a:p>
           <a:p>
@@ -5695,7 +5683,7 @@
                 </a:solidFill>
                 <a:latin typeface="Calibri"/>
               </a:rPr>
-              <a:t>•  Your year-end benefits check-up</a:t>
+              <a:t>•  The money change — parents' income counts differently</a:t>
             </a:r>
           </a:p>
           <a:p>
@@ -5707,7 +5695,31 @@
                 </a:solidFill>
                 <a:latin typeface="Calibri"/>
               </a:rPr>
-              <a:t>•  Turning 18 in 2027? Start now</a:t>
+              <a:t>•  The age-18 review: Social Security looks again</a:t>
+            </a:r>
+          </a:p>
+          <a:p>
+            <a:pPr algn="l"/>
+            <a:r>
+              <a:rPr sz="2700" b="0">
+                <a:solidFill>
+                  <a:srgbClr val="222222"/>
+                </a:solidFill>
+                <a:latin typeface="Calibri"/>
+              </a:rPr>
+              <a:t>•  DAC — the benefit on a parent's record</a:t>
+            </a:r>
+          </a:p>
+          <a:p>
+            <a:pPr algn="l"/>
+            <a:r>
+              <a:rPr sz="2700" b="0">
+                <a:solidFill>
+                  <a:srgbClr val="222222"/>
+                </a:solidFill>
+                <a:latin typeface="Calibri"/>
+              </a:rPr>
+              <a:t>•  Decisions at 18: who signs, who chooses</a:t>
             </a:r>
           </a:p>
           <a:p>
@@ -5731,19 +5743,7 @@
                 </a:solidFill>
                 <a:latin typeface="Calibri"/>
               </a:rPr>
-              <a:t>•  Protecting the parents</a:t>
-            </a:r>
-          </a:p>
-          <a:p>
-            <a:pPr algn="l"/>
-            <a:r>
-              <a:rPr sz="2700" b="0">
-                <a:solidFill>
-                  <a:srgbClr val="222222"/>
-                </a:solidFill>
-                <a:latin typeface="Calibri"/>
-              </a:rPr>
-              <a:t>•  Your January small steps + questions</a:t>
+              <a:t>•  Your first steps for January</a:t>
             </a:r>
           </a:p>
         </p:txBody>
@@ -5919,7 +5919,7 @@
                 </a:solidFill>
                 <a:latin typeface="Georgia"/>
               </a:rPr>
-              <a:t>What Is a Personal Plan?</a:t>
+              <a:t>Why 18 Changes Everything</a:t>
             </a:r>
           </a:p>
         </p:txBody>
@@ -5954,7 +5954,7 @@
                 </a:solidFill>
                 <a:latin typeface="Calibri"/>
               </a:rPr>
-              <a:t>•  A plan made only for YOUR child</a:t>
+              <a:t>•  At 18, your child is an adult in the eyes of the law</a:t>
             </a:r>
           </a:p>
           <a:p>
@@ -5966,7 +5966,7 @@
                 </a:solidFill>
                 <a:latin typeface="Calibri"/>
               </a:rPr>
-              <a:t>•  It puts benefits, medication, school and money in one order</a:t>
+              <a:t>•  Social Security switches from child rules to ADULT rules</a:t>
             </a:r>
           </a:p>
           <a:p>
@@ -5978,7 +5978,7 @@
                 </a:solidFill>
                 <a:latin typeface="Calibri"/>
               </a:rPr>
-              <a:t>•  It names the next steps — and who does them</a:t>
+              <a:t>•  School, doctors and banks treat them as adults too</a:t>
             </a:r>
           </a:p>
           <a:p>
@@ -5990,7 +5990,7 @@
                 </a:solidFill>
                 <a:latin typeface="Calibri"/>
               </a:rPr>
-              <a:t>•  For ages 5 to 26</a:t>
+              <a:t>•  Nothing about your love changes — the paperwork does</a:t>
             </a:r>
           </a:p>
         </p:txBody>
@@ -6166,7 +6166,7 @@
                 </a:solidFill>
                 <a:latin typeface="Georgia"/>
               </a:rPr>
-              <a:t>How a Plan Is Made</a:t>
+              <a:t>The Money Change</a:t>
             </a:r>
           </a:p>
         </p:txBody>
@@ -6201,7 +6201,7 @@
                 </a:solidFill>
                 <a:latin typeface="Calibri"/>
               </a:rPr>
-              <a:t>•  Step 1: Your free first talk — we listen</a:t>
+              <a:t>•  For a child, the parents' income counts in SSI</a:t>
             </a:r>
           </a:p>
           <a:p>
@@ -6213,7 +6213,7 @@
                 </a:solidFill>
                 <a:latin typeface="Calibri"/>
               </a:rPr>
-              <a:t>•  Step 2: We look at where your family is today</a:t>
+              <a:t>•  At 18, that counting changes — SSI looks at the young adult</a:t>
             </a:r>
           </a:p>
           <a:p>
@@ -6225,7 +6225,7 @@
                 </a:solidFill>
                 <a:latin typeface="Calibri"/>
               </a:rPr>
-              <a:t>•  Step 3: Your child's plan is built, step by step</a:t>
+              <a:t>•  Some teens who did NOT qualify before CAN qualify at 18</a:t>
             </a:r>
           </a:p>
           <a:p>
@@ -6237,7 +6237,7 @@
                 </a:solidFill>
                 <a:latin typeface="Calibri"/>
               </a:rPr>
-              <a:t>•  Step 4: We update it as life changes</a:t>
+              <a:t>•  Others must show their disability meets the adult rules</a:t>
             </a:r>
           </a:p>
         </p:txBody>
@@ -6413,7 +6413,7 @@
                 </a:solidFill>
                 <a:latin typeface="Georgia"/>
               </a:rPr>
-              <a:t>No Two Plans Are the Same</a:t>
+              <a:t>The Age-18 Review</a:t>
             </a:r>
           </a:p>
         </p:txBody>
@@ -6448,7 +6448,7 @@
                 </a:solidFill>
                 <a:latin typeface="Calibri"/>
               </a:rPr>
-              <a:t>•  A 7-year-old's plan is about school and benefits today</a:t>
+              <a:t>•  If your child gets SSI now, SSA reviews the case at 18</a:t>
             </a:r>
           </a:p>
           <a:p>
@@ -6460,7 +6460,7 @@
                 </a:solidFill>
                 <a:latin typeface="Calibri"/>
               </a:rPr>
-              <a:t>•  A 17-year-old's plan is about turning 18 and what changes</a:t>
+              <a:t>•  They use the adult disability rules for the review</a:t>
             </a:r>
           </a:p>
           <a:p>
@@ -6472,7 +6472,7 @@
                 </a:solidFill>
                 <a:latin typeface="Calibri"/>
               </a:rPr>
-              <a:t>•  A 24-year-old's plan is about work, benefits and living grown-up life</a:t>
+              <a:t>•  Doctor records and school records matter a lot</a:t>
             </a:r>
           </a:p>
           <a:p>
@@ -6484,7 +6484,7 @@
                 </a:solidFill>
                 <a:latin typeface="Calibri"/>
               </a:rPr>
-              <a:t>•  Every plan is unique — just like every disability</a:t>
+              <a:t>•  Keep every appointment and every paper this year</a:t>
             </a:r>
           </a:p>
         </p:txBody>
@@ -6660,7 +6660,7 @@
                 </a:solidFill>
                 <a:latin typeface="Georgia"/>
               </a:rPr>
-              <a:t>Your Year-End Benefits Check-Up</a:t>
+              <a:t>DAC: The Benefit Most Families Miss</a:t>
             </a:r>
           </a:p>
         </p:txBody>
@@ -6695,7 +6695,7 @@
                 </a:solidFill>
                 <a:latin typeface="Calibri"/>
               </a:rPr>
-              <a:t>•  Read any letters from Social Security — do not stack them unopened</a:t>
+              <a:t>•  DAC = Disabled Adult Child benefits</a:t>
             </a:r>
           </a:p>
           <a:p>
@@ -6707,7 +6707,7 @@
                 </a:solidFill>
                 <a:latin typeface="Calibri"/>
               </a:rPr>
-              <a:t>•  Check your child's medication list is current</a:t>
+              <a:t>•  For an adult whose disability began before age 22</a:t>
             </a:r>
           </a:p>
           <a:p>
@@ -6719,7 +6719,7 @@
                 </a:solidFill>
                 <a:latin typeface="Calibri"/>
               </a:rPr>
-              <a:t>•  Look at the school plan (504) — is it working?</a:t>
+              <a:t>•  It pays on a PARENT'S work record</a:t>
             </a:r>
           </a:p>
           <a:p>
@@ -6731,7 +6731,19 @@
                 </a:solidFill>
                 <a:latin typeface="Calibri"/>
               </a:rPr>
-              <a:t>•  Note any big changes coming in 2027</a:t>
+              <a:t>•  A parent must be retired, disabled, or passed away</a:t>
+            </a:r>
+          </a:p>
+          <a:p>
+            <a:pPr algn="l"/>
+            <a:r>
+              <a:rPr sz="2700" b="0">
+                <a:solidFill>
+                  <a:srgbClr val="222222"/>
+                </a:solidFill>
+                <a:latin typeface="Calibri"/>
+              </a:rPr>
+              <a:t>•  Before a parent files for retirement — ASK FIRST. The order of filings can protect Medicaid.</a:t>
             </a:r>
           </a:p>
         </p:txBody>
@@ -6907,7 +6919,7 @@
                 </a:solidFill>
                 <a:latin typeface="Georgia"/>
               </a:rPr>
-              <a:t>Turning 18 in 2027? Start Now</a:t>
+              <a:t>Decisions at 18: Who Signs, Who Chooses</a:t>
             </a:r>
           </a:p>
         </p:txBody>
@@ -6942,7 +6954,7 @@
                 </a:solidFill>
                 <a:latin typeface="Calibri"/>
               </a:rPr>
-              <a:t>•  At 18, Social Security uses adult rules</a:t>
+              <a:t>•  At 18, your young adult signs for themselves — unless steps are taken</a:t>
             </a:r>
           </a:p>
           <a:p>
@@ -6954,7 +6966,7 @@
                 </a:solidFill>
                 <a:latin typeface="Calibri"/>
               </a:rPr>
-              <a:t>•  The parents' income stops counting the same way</a:t>
+              <a:t>•  Families ask about guardianship and other choices</a:t>
             </a:r>
           </a:p>
           <a:p>
@@ -6966,7 +6978,7 @@
                 </a:solidFill>
                 <a:latin typeface="Calibri"/>
               </a:rPr>
-              <a:t>•  Papers and doctor records matter more than ever</a:t>
+              <a:t>•  There are options, and they are legal decisions</a:t>
             </a:r>
           </a:p>
           <a:p>
@@ -6978,7 +6990,7 @@
                 </a:solidFill>
                 <a:latin typeface="Calibri"/>
               </a:rPr>
-              <a:t>•  Starting early makes the change much smoother</a:t>
+              <a:t>•  We are not attorneys — we help you get ready to talk to one</a:t>
             </a:r>
           </a:p>
         </p:txBody>
@@ -7154,7 +7166,7 @@
                 </a:solidFill>
                 <a:latin typeface="Georgia"/>
               </a:rPr>
-              <a:t>Papers to Gather Over the Holidays</a:t>
+              <a:t>School at 18</a:t>
             </a:r>
           </a:p>
         </p:txBody>
@@ -7189,7 +7201,7 @@
                 </a:solidFill>
                 <a:latin typeface="Calibri"/>
               </a:rPr>
-              <a:t>•  Your child's ID and Social Security card (copies)</a:t>
+              <a:t>•  Rights at school move to the student at 18</a:t>
             </a:r>
           </a:p>
           <a:p>
@@ -7201,7 +7213,7 @@
                 </a:solidFill>
                 <a:latin typeface="Calibri"/>
               </a:rPr>
-              <a:t>•  Letters from Social Security</a:t>
+              <a:t>•  A 504 plan can continue — ask the school how they handle it</a:t>
             </a:r>
           </a:p>
           <a:p>
@@ -7213,7 +7225,7 @@
                 </a:solidFill>
                 <a:latin typeface="Calibri"/>
               </a:rPr>
-              <a:t>•  A list of doctors, clinics and medicines</a:t>
+              <a:t>•  Transition planning should name work, training and daily life</a:t>
             </a:r>
           </a:p>
           <a:p>
@@ -7225,19 +7237,7 @@
                 </a:solidFill>
                 <a:latin typeface="Calibri"/>
               </a:rPr>
-              <a:t>•  School papers — the current 504 plan</a:t>
-            </a:r>
-          </a:p>
-          <a:p>
-            <a:pPr algn="l"/>
-            <a:r>
-              <a:rPr sz="2700" b="0">
-                <a:solidFill>
-                  <a:srgbClr val="222222"/>
-                </a:solidFill>
-                <a:latin typeface="Calibri"/>
-              </a:rPr>
-              <a:t>•  Any guardianship or court papers</a:t>
+              <a:t>•  Keep the current school papers in your folder</a:t>
             </a:r>
           </a:p>
         </p:txBody>
@@ -7413,7 +7413,7 @@
                 </a:solidFill>
                 <a:latin typeface="Georgia"/>
               </a:rPr>
-              <a:t>Medication List Refresh</a:t>
+              <a:t>The Papers to Gather Over the Holidays</a:t>
             </a:r>
           </a:p>
         </p:txBody>
@@ -7448,7 +7448,7 @@
                 </a:solidFill>
                 <a:latin typeface="Calibri"/>
               </a:rPr>
-              <a:t>•  Start January with one clean medication list</a:t>
+              <a:t>•  Your teen's ID and Social Security card (copies)</a:t>
             </a:r>
           </a:p>
           <a:p>
@@ -7460,7 +7460,7 @@
                 </a:solidFill>
                 <a:latin typeface="Calibri"/>
               </a:rPr>
-              <a:t>•  Name, dose, and what it is for — for every medicine</a:t>
+              <a:t>•  Letters from Social Security</a:t>
             </a:r>
           </a:p>
           <a:p>
@@ -7472,7 +7472,7 @@
                 </a:solidFill>
                 <a:latin typeface="Calibri"/>
               </a:rPr>
-              <a:t>•  A medication check can look for ways to lower costs</a:t>
+              <a:t>•  A list of doctors, clinics and medicines</a:t>
             </a:r>
           </a:p>
           <a:p>
@@ -7484,7 +7484,19 @@
                 </a:solidFill>
                 <a:latin typeface="Calibri"/>
               </a:rPr>
-              <a:t>•  Your medication check at Southern Oak is always FREE</a:t>
+              <a:t>•  School papers — the current 504 plan</a:t>
+            </a:r>
+          </a:p>
+          <a:p>
+            <a:pPr algn="l"/>
+            <a:r>
+              <a:rPr sz="2700" b="0">
+                <a:solidFill>
+                  <a:srgbClr val="222222"/>
+                </a:solidFill>
+                <a:latin typeface="Calibri"/>
+              </a:rPr>
+              <a:t>•  Any guardianship or court papers</a:t>
             </a:r>
           </a:p>
         </p:txBody>

</xml_diff>